<commit_message>
USA statistical techniques: 5 decks rewritten from the teacher's course support
Quantitative Techniques 2 (data collection) and 4 (graphs) rebuilt natively,
and Quantitative Techniques 3 split into three decks following the teacher's
programme: central tendency, range and quartiles; variance, standard deviation
and coefficient of variation; Spearman's rank correlation with significance.
All worked examples recalculated. The overlay helper now lets several new
lessons replace one old lesson.

Co-Authored-By: Claude Opus 5.5 <noreply@anthropic.com>
Claude-Session: https://claude.ai/code/session_0115LFSb2ktGLWPeVksFkSer
</commit_message>
<xml_diff>
--- a/lecons/USA/Practical Geography/01_USA_PRA_MA01_Review_of_Map_Reading_Principles.pptx
+++ b/lecons/USA/Practical Geography/01_USA_PRA_MA01_Review_of_Map_Reading_Principles.pptx
@@ -13866,7 +13866,7 @@
               <a:buNone/>
             </a:pPr>
             <a:r>
-              <a:rPr lang="en-US" sz="4000" b="1" dirty="0">
+              <a:rPr lang="en-US" sz="3200" b="1" dirty="0">
                 <a:solidFill>
                   <a:srgbClr val="111111"/>
                 </a:solidFill>
@@ -13876,7 +13876,7 @@
               </a:rPr>
               <a:t>Topic: Topographic Map Analysis</a:t>
             </a:r>
-            <a:endParaRPr lang="en-US" sz="4000" dirty="0"/>
+            <a:endParaRPr lang="en-US" sz="3200" dirty="0"/>
           </a:p>
           <a:p>
             <a:pPr algn="l" indent="0" marL="0">
@@ -13886,7 +13886,7 @@
               <a:buNone/>
             </a:pPr>
             <a:r>
-              <a:rPr lang="en-US" sz="4000" b="1" dirty="0">
+              <a:rPr lang="en-US" sz="3200" b="1" dirty="0">
                 <a:solidFill>
                   <a:srgbClr val="111111"/>
                 </a:solidFill>
@@ -13896,7 +13896,7 @@
               </a:rPr>
               <a:t>Sub-topic: Review of map reading of the first cycle</a:t>
             </a:r>
-            <a:endParaRPr lang="en-US" sz="4000" dirty="0"/>
+            <a:endParaRPr lang="en-US" sz="3200" dirty="0"/>
           </a:p>
           <a:p>
             <a:pPr algn="l" indent="0" marL="0">
@@ -13906,7 +13906,7 @@
               <a:buNone/>
             </a:pPr>
             <a:r>
-              <a:rPr lang="en-US" sz="4000" b="1" dirty="0">
+              <a:rPr lang="en-US" sz="3200" b="1" dirty="0">
                 <a:solidFill>
                   <a:srgbClr val="990011"/>
                 </a:solidFill>
@@ -13916,7 +13916,7 @@
               </a:rPr>
               <a:t>Map Analysis 1: Review of Map Reading Principles</a:t>
             </a:r>
-            <a:endParaRPr lang="en-US" sz="4000" dirty="0"/>
+            <a:endParaRPr lang="en-US" sz="3200" dirty="0"/>
           </a:p>
         </p:txBody>
       </p:sp>

</xml_diff>